<commit_message>
Recast session 9 as "next-session prep" with 4 deliverables
Replace the AIDMA/Lovable-only structure with four concrete artifacts
that next session's LINE setup can drop straight into:
- Basic ex1: LP / Web page auto-generation (Lovable)
- Basic ex2: 公式LINE 構成 (AIDMA, あいさつ文 + Day1-3 配信本文)
- Applied ex1: リッチメニュー 1枚(2500x1686, タップ座標表付き)
- Applied ex2: アイコン画像(640x640, 人物/AI/ストック の選定)

Every exercise ends by saving the result into a "次回引き継ぎ" Drive
folder so session 10 can start with upload-only work.

https://claude.ai/code/session_01MLnStsm4YQNeGye3rc2BGH
</commit_message>
<xml_diff>
--- a/lecture_pptx/out/work01.pptx
+++ b/lecture_pptx/out/work01.pptx
@@ -1551,7 +1551,7 @@
                 <a:ea typeface="Yu Gothic UI Semibold" pitchFamily="34" charset="-122"/>
                 <a:cs typeface="Yu Gothic UI Semibold" pitchFamily="34" charset="-120"/>
               </a:rPr>
-              <a:t>Lovable で LP をバイブコーディング</a:t>
+              <a:t>LP 自動生成 + 公式LINE 構成設計</a:t>
             </a:r>
             <a:endParaRPr lang="en-US" sz="3400" dirty="0"/>
           </a:p>
@@ -1590,7 +1590,7 @@
                 <a:ea typeface="Yu Gothic UI" pitchFamily="34" charset="-122"/>
                 <a:cs typeface="Yu Gothic UI" pitchFamily="34" charset="-120"/>
               </a:rPr>
-              <a:t>AI に頼んで「ブランディング3軸」を反映した LP を世に出す</a:t>
+              <a:t>次回の公式LINE設定に「すぐ入れる」素材を、AIで一気に仕上げる</a:t>
             </a:r>
             <a:endParaRPr lang="en-US" sz="1600" dirty="0"/>
           </a:p>
@@ -1806,7 +1806,7 @@
                 <a:ea typeface="Yu Gothic UI Semibold" pitchFamily="34" charset="-122"/>
                 <a:cs typeface="Yu Gothic UI Semibold" pitchFamily="34" charset="-120"/>
               </a:rPr>
-              <a:t>AIに頼んで LP を作る</a:t>
+              <a:t>LP/Webページを生成</a:t>
             </a:r>
             <a:endParaRPr lang="en-US" sz="1400" dirty="0"/>
           </a:p>
@@ -1845,7 +1845,7 @@
                 <a:ea typeface="Yu Gothic UI" pitchFamily="34" charset="-122"/>
                 <a:cs typeface="Yu Gothic UI" pitchFamily="34" charset="-120"/>
               </a:rPr>
-              <a:t>Lovable に日本語で要件を伝えて、自分の3軸を反映した LP を生成する。</a:t>
+              <a:t>Lovable に日本語で頼んで、自分の3軸を反映した LP を1ページ作る。</a:t>
             </a:r>
             <a:endParaRPr lang="en-US" sz="1100" dirty="0"/>
           </a:p>
@@ -1970,7 +1970,7 @@
                 <a:ea typeface="Yu Gothic UI Semibold" pitchFamily="34" charset="-122"/>
                 <a:cs typeface="Yu Gothic UI Semibold" pitchFamily="34" charset="-120"/>
               </a:rPr>
-              <a:t>公開URLまで持っていく</a:t>
+              <a:t>公式LINE 構成を設計</a:t>
             </a:r>
             <a:endParaRPr lang="en-US" sz="1400" dirty="0"/>
           </a:p>
@@ -2009,7 +2009,7 @@
                 <a:ea typeface="Yu Gothic UI" pitchFamily="34" charset="-122"/>
                 <a:cs typeface="Yu Gothic UI" pitchFamily="34" charset="-120"/>
               </a:rPr>
-              <a:t>生成→修正→デプロイの流れを実体験し、公開URLとして仕上げる。</a:t>
+              <a:t>AIDMA に沿って「あいさつ→価値→予約」までの流れを文章で固める。</a:t>
             </a:r>
             <a:endParaRPr lang="en-US" sz="1100" dirty="0"/>
           </a:p>
@@ -2134,7 +2134,7 @@
                 <a:ea typeface="Yu Gothic UI Semibold" pitchFamily="34" charset="-122"/>
                 <a:cs typeface="Yu Gothic UI Semibold" pitchFamily="34" charset="-120"/>
               </a:rPr>
-              <a:t>公式LINE登録ボタンを設置</a:t>
+              <a:t>次回への引き継ぎ</a:t>
             </a:r>
             <a:endParaRPr lang="en-US" sz="1400" dirty="0"/>
           </a:p>
@@ -2173,7 +2173,7 @@
                 <a:ea typeface="Yu Gothic UI" pitchFamily="34" charset="-122"/>
                 <a:cs typeface="Yu Gothic UI" pitchFamily="34" charset="-120"/>
               </a:rPr>
-              <a:t>LP の最後に CTA として公式LINE 登録ボタンを置き、動線の入口を完成。</a:t>
+              <a:t>LP の URL と LINE 構成文を、次回そのまま設定画面に流し込める形にする。</a:t>
             </a:r>
             <a:endParaRPr lang="en-US" sz="1100" dirty="0"/>
           </a:p>
@@ -2264,7 +2264,7 @@
                 <a:ea typeface="Yu Gothic UI Semibold" pitchFamily="34" charset="-122"/>
                 <a:cs typeface="Yu Gothic UI Semibold" pitchFamily="34" charset="-120"/>
               </a:rPr>
-              <a:t>用語と前提</a:t>
+              <a:t>STEP1: 用語と前提</a:t>
             </a:r>
             <a:endParaRPr lang="en-US" sz="2200" dirty="0"/>
           </a:p>
@@ -2414,7 +2414,7 @@
                 <a:ea typeface="Yu Gothic UI" pitchFamily="34" charset="-122"/>
                 <a:cs typeface="Yu Gothic UI" pitchFamily="34" charset="-120"/>
               </a:rPr>
-              <a:t>AIに「こんなWebサイトが欲しい」と日本語で頼むだけでコードを書いてくれる、ノーコード生成ツール。</a:t>
+              <a:t>AIに「こんな Web サイトが欲しい」と日本語で頼むだけでコードを書いてくれる、ノーコード生成ツール。</a:t>
             </a:r>
             <a:endParaRPr lang="en-US" sz="1100" dirty="0"/>
           </a:p>
@@ -2522,7 +2522,7 @@
                 <a:ea typeface="Yu Gothic UI Semibold" pitchFamily="34" charset="-122"/>
                 <a:cs typeface="Yu Gothic UI Semibold" pitchFamily="34" charset="-120"/>
               </a:rPr>
-              <a:t>LP（ランディングページ）</a:t>
+              <a:t>LP(ランディングページ)</a:t>
             </a:r>
             <a:endParaRPr lang="en-US" sz="1300" dirty="0"/>
           </a:p>
@@ -2564,7 +2564,7 @@
                 <a:ea typeface="Yu Gothic UI" pitchFamily="34" charset="-122"/>
                 <a:cs typeface="Yu Gothic UI" pitchFamily="34" charset="-120"/>
               </a:rPr>
-              <a:t>SNS や広告から訪れた人が「最初に着地する」1ページのサイト。商談予約や登録の入口にする。</a:t>
+              <a:t>SNS や広告から訪れた人が最初に「着地する」1ページ。商談予約や登録の入口にする。</a:t>
             </a:r>
             <a:endParaRPr lang="en-US" sz="1100" dirty="0"/>
           </a:p>
@@ -2672,7 +2672,7 @@
                 <a:ea typeface="Yu Gothic UI Semibold" pitchFamily="34" charset="-122"/>
                 <a:cs typeface="Yu Gothic UI Semibold" pitchFamily="34" charset="-120"/>
               </a:rPr>
-              <a:t>バイブコーディング</a:t>
+              <a:t>AIDMA</a:t>
             </a:r>
             <a:endParaRPr lang="en-US" sz="1300" dirty="0"/>
           </a:p>
@@ -2714,7 +2714,7 @@
                 <a:ea typeface="Yu Gothic UI" pitchFamily="34" charset="-122"/>
                 <a:cs typeface="Yu Gothic UI" pitchFamily="34" charset="-120"/>
               </a:rPr>
-              <a:t>コードを書かず、日本語でやりたいことを AI に伝えて修正を重ねながら形にする作り方。</a:t>
+              <a:t>注目→興味→欲求→記憶→行動 の5段階で、人の購買心理を表したマーケティングの基本フレーム。</a:t>
             </a:r>
             <a:endParaRPr lang="en-US" sz="1100" dirty="0"/>
           </a:p>
@@ -2822,7 +2822,7 @@
                 <a:ea typeface="Yu Gothic UI Semibold" pitchFamily="34" charset="-122"/>
                 <a:cs typeface="Yu Gothic UI Semibold" pitchFamily="34" charset="-120"/>
               </a:rPr>
-              <a:t>CTA（行動喚起）</a:t>
+              <a:t>バイブコーディング</a:t>
             </a:r>
             <a:endParaRPr lang="en-US" sz="1300" dirty="0"/>
           </a:p>
@@ -2864,7 +2864,7 @@
                 <a:ea typeface="Yu Gothic UI" pitchFamily="34" charset="-122"/>
                 <a:cs typeface="Yu Gothic UI" pitchFamily="34" charset="-120"/>
               </a:rPr>
-              <a:t>「公式LINE登録」「予約する」など、訪問者にして欲しい行動を促すボタンや文言。</a:t>
+              <a:t>コードを書かず、日本語でやりたいことを AI に伝えて修正を重ねながら形にする作り方。</a:t>
             </a:r>
             <a:endParaRPr lang="en-US" sz="1100" dirty="0"/>
           </a:p>
@@ -2931,7 +2931,7 @@
                 <a:ea typeface="Yu Gothic UI" pitchFamily="34" charset="-122"/>
                 <a:cs typeface="Yu Gothic UI" pitchFamily="34" charset="-120"/>
               </a:rPr>
-              <a:t>ブラウザだけで使え、無料枠あり。生成結果は自分のドメインで公開可能   </a:t>
+              <a:t>ブラウザだけで使え、無料枠あり   </a:t>
             </a:r>
             <a:pPr indent="0" marL="0">
               <a:buNone/>
@@ -2959,7 +2959,7 @@
                 <a:ea typeface="Yu Gothic UI" pitchFamily="34" charset="-122"/>
                 <a:cs typeface="Yu Gothic UI" pitchFamily="34" charset="-120"/>
               </a:rPr>
-              <a:t>LP（ランディングページ）: </a:t>
+              <a:t>LP(ランディングページ): </a:t>
             </a:r>
             <a:pPr indent="0" marL="0">
               <a:buNone/>
@@ -2973,7 +2973,7 @@
                 <a:ea typeface="Yu Gothic UI" pitchFamily="34" charset="-122"/>
                 <a:cs typeface="Yu Gothic UI" pitchFamily="34" charset="-120"/>
               </a:rPr>
-              <a:t>ホームページとの違いは「1つの行動」だけを促す設計のこと   </a:t>
+              <a:t>1つの行動だけを促す設計が大事   </a:t>
             </a:r>
             <a:pPr indent="0" marL="0">
               <a:buNone/>
@@ -3001,6 +3001,48 @@
                 <a:ea typeface="Yu Gothic UI" pitchFamily="34" charset="-122"/>
                 <a:cs typeface="Yu Gothic UI" pitchFamily="34" charset="-120"/>
               </a:rPr>
+              <a:t>AIDMA: </a:t>
+            </a:r>
+            <a:pPr indent="0" marL="0">
+              <a:buNone/>
+            </a:pPr>
+            <a:r>
+              <a:rPr lang="en-US" sz="950" dirty="0">
+                <a:solidFill>
+                  <a:srgbClr val="555555"/>
+                </a:solidFill>
+                <a:latin typeface="Yu Gothic UI" pitchFamily="34" charset="0"/>
+                <a:ea typeface="Yu Gothic UI" pitchFamily="34" charset="-122"/>
+                <a:cs typeface="Yu Gothic UI" pitchFamily="34" charset="-120"/>
+              </a:rPr>
+              <a:t>LINE 配信の順番設計に使う   </a:t>
+            </a:r>
+            <a:pPr indent="0" marL="0">
+              <a:buNone/>
+            </a:pPr>
+            <a:r>
+              <a:rPr lang="en-US" sz="950" b="1" dirty="0">
+                <a:solidFill>
+                  <a:srgbClr val="E8A33D"/>
+                </a:solidFill>
+                <a:latin typeface="Yu Gothic UI" pitchFamily="34" charset="0"/>
+                <a:ea typeface="Yu Gothic UI" pitchFamily="34" charset="-122"/>
+                <a:cs typeface="Yu Gothic UI" pitchFamily="34" charset="-120"/>
+              </a:rPr>
+              <a:t>※ </a:t>
+            </a:r>
+            <a:pPr indent="0" marL="0">
+              <a:buNone/>
+            </a:pPr>
+            <a:r>
+              <a:rPr lang="en-US" sz="950" b="1" dirty="0">
+                <a:solidFill>
+                  <a:srgbClr val="1F3A5F"/>
+                </a:solidFill>
+                <a:latin typeface="Yu Gothic UI" pitchFamily="34" charset="0"/>
+                <a:ea typeface="Yu Gothic UI" pitchFamily="34" charset="-122"/>
+                <a:cs typeface="Yu Gothic UI" pitchFamily="34" charset="-120"/>
+              </a:rPr>
               <a:t>バイブコーディング: </a:t>
             </a:r>
             <a:pPr indent="0" marL="0">
@@ -3015,49 +3057,7 @@
                 <a:ea typeface="Yu Gothic UI" pitchFamily="34" charset="-122"/>
                 <a:cs typeface="Yu Gothic UI" pitchFamily="34" charset="-120"/>
               </a:rPr>
-              <a:t>空気感(vibe)で指示するスタイル   </a:t>
-            </a:r>
-            <a:pPr indent="0" marL="0">
-              <a:buNone/>
-            </a:pPr>
-            <a:r>
-              <a:rPr lang="en-US" sz="950" b="1" dirty="0">
-                <a:solidFill>
-                  <a:srgbClr val="E8A33D"/>
-                </a:solidFill>
-                <a:latin typeface="Yu Gothic UI" pitchFamily="34" charset="0"/>
-                <a:ea typeface="Yu Gothic UI" pitchFamily="34" charset="-122"/>
-                <a:cs typeface="Yu Gothic UI" pitchFamily="34" charset="-120"/>
-              </a:rPr>
-              <a:t>※ </a:t>
-            </a:r>
-            <a:pPr indent="0" marL="0">
-              <a:buNone/>
-            </a:pPr>
-            <a:r>
-              <a:rPr lang="en-US" sz="950" b="1" dirty="0">
-                <a:solidFill>
-                  <a:srgbClr val="1F3A5F"/>
-                </a:solidFill>
-                <a:latin typeface="Yu Gothic UI" pitchFamily="34" charset="0"/>
-                <a:ea typeface="Yu Gothic UI" pitchFamily="34" charset="-122"/>
-                <a:cs typeface="Yu Gothic UI" pitchFamily="34" charset="-120"/>
-              </a:rPr>
-              <a:t>CTA（行動喚起）: </a:t>
-            </a:r>
-            <a:pPr indent="0" marL="0">
-              <a:buNone/>
-            </a:pPr>
-            <a:r>
-              <a:rPr lang="en-US" sz="950" dirty="0">
-                <a:solidFill>
-                  <a:srgbClr val="555555"/>
-                </a:solidFill>
-                <a:latin typeface="Yu Gothic UI" pitchFamily="34" charset="0"/>
-                <a:ea typeface="Yu Gothic UI" pitchFamily="34" charset="-122"/>
-                <a:cs typeface="Yu Gothic UI" pitchFamily="34" charset="-120"/>
-              </a:rPr>
-              <a:t>Call To Action の略   </a:t>
+              <a:t>空気感(vibe)で指示する   </a:t>
             </a:r>
             <a:endParaRPr lang="en-US" sz="950" dirty="0"/>
           </a:p>
@@ -3148,7 +3148,7 @@
                 <a:ea typeface="Yu Gothic UI Semibold" pitchFamily="34" charset="-122"/>
                 <a:cs typeface="Yu Gothic UI Semibold" pitchFamily="34" charset="-120"/>
               </a:rPr>
-              <a:t>演習1 LP のたたき台を Lovable で生成</a:t>
+              <a:t>演習1 LP/Webページを Lovable で自動生成</a:t>
             </a:r>
             <a:endParaRPr lang="en-US" sz="2200" dirty="0"/>
           </a:p>
@@ -3276,7 +3276,7 @@
                 <a:ea typeface="Yu Gothic UI" pitchFamily="34" charset="-122"/>
                 <a:cs typeface="Yu Gothic UI" pitchFamily="34" charset="-120"/>
               </a:rPr>
-              <a:t>ブランディング3軸（誰に・何を・どの立ち位置で）は前回整理済み。</a:t>
+              <a:t>ブランディング3軸(誰に・何を・どの立ち位置で)は前回整理済み。</a:t>
             </a:r>
             <a:endParaRPr lang="en-US" sz="1150" dirty="0"/>
           </a:p>
@@ -3681,6 +3681,27 @@
                 <a:cs typeface="Yu Gothic UI" pitchFamily="34" charset="-120"/>
               </a:rPr>
               <a:t>最下部に「公式LINEで無料相談」などの CTA ボタンを置く</a:t>
+            </a:r>
+            <a:endParaRPr lang="en-US" sz="1150" dirty="0"/>
+          </a:p>
+          <a:p>
+            <a:pPr marL="342900" indent="-342900">
+              <a:spcAft>
+                <a:spcPts val="400"/>
+              </a:spcAft>
+              <a:buSzPct val="100000"/>
+              <a:buChar char="●"/>
+            </a:pPr>
+            <a:r>
+              <a:rPr lang="en-US" sz="1150" dirty="0">
+                <a:solidFill>
+                  <a:srgbClr val="1A1A1A"/>
+                </a:solidFill>
+                <a:latin typeface="Yu Gothic UI" pitchFamily="34" charset="0"/>
+                <a:ea typeface="Yu Gothic UI" pitchFamily="34" charset="-122"/>
+                <a:cs typeface="Yu Gothic UI" pitchFamily="34" charset="-120"/>
+              </a:rPr>
+              <a:t>生成された LP の公開URL を控えておく(次回で公式LINEに紐付け)</a:t>
             </a:r>
             <a:endParaRPr lang="en-US" sz="1150" dirty="0"/>
           </a:p>
@@ -3771,7 +3792,7 @@
                 <a:ea typeface="Yu Gothic UI Semibold" pitchFamily="34" charset="-122"/>
                 <a:cs typeface="Yu Gothic UI Semibold" pitchFamily="34" charset="-120"/>
               </a:rPr>
-              <a:t>演習1 LP のたたき台を Lovable で生成 — 観点別チェック</a:t>
+              <a:t>演習1 LP/Webページを Lovable で自動生成 — 観点別チェック</a:t>
             </a:r>
             <a:endParaRPr lang="en-US" sz="2200" dirty="0"/>
           </a:p>
@@ -4594,7 +4615,7 @@
                 <a:ea typeface="Yu Gothic UI Semibold" pitchFamily="34" charset="-122"/>
                 <a:cs typeface="Yu Gothic UI Semibold" pitchFamily="34" charset="-120"/>
               </a:rPr>
-              <a:t>演習2 LP→公式LINE→面談予約 の動線を設計</a:t>
+              <a:t>演習2 公式LINE の構成を考える</a:t>
             </a:r>
             <a:endParaRPr lang="en-US" sz="2200" dirty="0"/>
           </a:p>
@@ -4722,7 +4743,7 @@
                 <a:ea typeface="Yu Gothic UI" pitchFamily="34" charset="-122"/>
                 <a:cs typeface="Yu Gothic UI" pitchFamily="34" charset="-120"/>
               </a:rPr>
-              <a:t>LP の骨格はできた。次は登録〜面談予約までの動線を AI に整理してもらいたい。</a:t>
+              <a:t>次回は公式LINE を実際に設定する回。今回は「何を / どう配信するか」の構成を文章で固めておく。</a:t>
             </a:r>
             <a:endParaRPr lang="en-US" sz="1150" dirty="0"/>
           </a:p>
@@ -4742,7 +4763,7 @@
                 <a:ea typeface="Yu Gothic UI" pitchFamily="34" charset="-122"/>
                 <a:cs typeface="Yu Gothic UI" pitchFamily="34" charset="-120"/>
               </a:rPr>
-              <a:t>AIDMA(注目→興味→欲求→記憶→行動) に沿って LINE の流れを設計する。</a:t>
+              <a:t>AIDMA に沿って、登録〜面談予約までの流れを設計する。</a:t>
             </a:r>
             <a:endParaRPr lang="en-US" sz="1150" dirty="0"/>
           </a:p>
@@ -4871,7 +4892,7 @@
                 <a:ea typeface="Yu Gothic UI" pitchFamily="34" charset="-122"/>
                 <a:cs typeface="Yu Gothic UI" pitchFamily="34" charset="-120"/>
               </a:rPr>
-              <a:t>生成 AI に「保険営業の公式LINEを AIDMA で設計して」と頼む</a:t>
+              <a:t>生成AIに「保険営業の公式LINEを AIDMA で設計して」と依頼</a:t>
             </a:r>
             <a:endParaRPr lang="en-US" sz="1150" dirty="0"/>
           </a:p>
@@ -4913,7 +4934,28 @@
                 <a:ea typeface="Yu Gothic UI" pitchFamily="34" charset="-122"/>
                 <a:cs typeface="Yu Gothic UI" pitchFamily="34" charset="-120"/>
               </a:rPr>
-              <a:t>出力された設計をスプレッドシートに表形式で貼り、優先順位を付ける</a:t>
+              <a:t>出力された設計をスプレッドシートに表形式で貼り、次回そのまま流し込める状態に</a:t>
+            </a:r>
+            <a:endParaRPr lang="en-US" sz="1150" dirty="0"/>
+          </a:p>
+          <a:p>
+            <a:pPr marL="342900" indent="-342900">
+              <a:spcAft>
+                <a:spcPts val="400"/>
+              </a:spcAft>
+              <a:buSzPct val="100000"/>
+              <a:buChar char="●"/>
+            </a:pPr>
+            <a:r>
+              <a:rPr lang="en-US" sz="1150" dirty="0">
+                <a:solidFill>
+                  <a:srgbClr val="1A1A1A"/>
+                </a:solidFill>
+                <a:latin typeface="Yu Gothic UI" pitchFamily="34" charset="0"/>
+                <a:ea typeface="Yu Gothic UI" pitchFamily="34" charset="-122"/>
+                <a:cs typeface="Yu Gothic UI" pitchFamily="34" charset="-120"/>
+              </a:rPr>
+              <a:t>本文は短文で、改行・絵文字を入れ「LINE で読みやすい形」を意識</a:t>
             </a:r>
             <a:endParaRPr lang="en-US" sz="1150" dirty="0"/>
           </a:p>
@@ -5063,7 +5105,7 @@
                 <a:ea typeface="Yu Gothic UI" pitchFamily="34" charset="-122"/>
                 <a:cs typeface="Yu Gothic UI" pitchFamily="34" charset="-120"/>
               </a:rPr>
-              <a:t>面談予約までのステップ数を3〜5に絞り、各ステップの目的を明記</a:t>
+              <a:t>登録直後のあいさつ文(自動応答)の文案を1つ作る</a:t>
             </a:r>
             <a:endParaRPr lang="en-US" sz="1150" dirty="0"/>
           </a:p>
@@ -5084,7 +5126,28 @@
                 <a:ea typeface="Yu Gothic UI" pitchFamily="34" charset="-122"/>
                 <a:cs typeface="Yu Gothic UI" pitchFamily="34" charset="-120"/>
               </a:rPr>
-              <a:t>公式LINE 登録直後のあいさつ文(自動応答)の文案を1つ作る</a:t>
+              <a:t>ステップ配信の本文(Day1〜Day3)を下書きする</a:t>
+            </a:r>
+            <a:endParaRPr lang="en-US" sz="1150" dirty="0"/>
+          </a:p>
+          <a:p>
+            <a:pPr marL="342900" indent="-342900">
+              <a:spcAft>
+                <a:spcPts val="400"/>
+              </a:spcAft>
+              <a:buSzPct val="100000"/>
+              <a:buChar char="●"/>
+            </a:pPr>
+            <a:r>
+              <a:rPr lang="en-US" sz="1150" dirty="0">
+                <a:solidFill>
+                  <a:srgbClr val="1A1A1A"/>
+                </a:solidFill>
+                <a:latin typeface="Yu Gothic UI" pitchFamily="34" charset="0"/>
+                <a:ea typeface="Yu Gothic UI" pitchFamily="34" charset="-122"/>
+                <a:cs typeface="Yu Gothic UI" pitchFamily="34" charset="-120"/>
+              </a:rPr>
+              <a:t>最後の「行動」段階での予約案内の文言を作る</a:t>
             </a:r>
             <a:endParaRPr lang="en-US" sz="1150" dirty="0"/>
           </a:p>
@@ -5175,7 +5238,7 @@
                 <a:ea typeface="Yu Gothic UI Semibold" pitchFamily="34" charset="-122"/>
                 <a:cs typeface="Yu Gothic UI Semibold" pitchFamily="34" charset="-120"/>
               </a:rPr>
-              <a:t>演習2 LP→公式LINE→面談予約 の動線を設計 — 観点別チェック</a:t>
+              <a:t>演習2 公式LINE の構成を考える — 観点別チェック</a:t>
             </a:r>
             <a:endParaRPr lang="en-US" sz="2200" dirty="0"/>
           </a:p>
@@ -5570,7 +5633,7 @@
                 <a:ea typeface="Yu Gothic UI Semibold" pitchFamily="34" charset="-122"/>
                 <a:cs typeface="Yu Gothic UI Semibold" pitchFamily="34" charset="-120"/>
               </a:rPr>
-              <a:t>B. 離脱対策</a:t>
+              <a:t>B. 配信本文の手触り</a:t>
             </a:r>
             <a:endParaRPr lang="en-US" sz="1200" dirty="0"/>
           </a:p>
@@ -5623,7 +5686,7 @@
                 <a:ea typeface="Yu Gothic UI" pitchFamily="34" charset="-122"/>
                 <a:cs typeface="Yu Gothic UI" pitchFamily="34" charset="-120"/>
               </a:rPr>
-              <a:t>各段階で「離脱しそうな人」へのフォロー文が用意できているか</a:t>
+              <a:t>スマホ画面で読むことを意識した、短文+改行の配信文になっているか</a:t>
             </a:r>
             <a:endParaRPr lang="en-US" sz="1050" dirty="0"/>
           </a:p>
@@ -5676,7 +5739,7 @@
                 <a:ea typeface="Yu Gothic UI" pitchFamily="34" charset="-122"/>
                 <a:cs typeface="Yu Gothic UI" pitchFamily="34" charset="-120"/>
               </a:rPr>
-              <a:t>「迷っている方へ」「もし不安があれば」などの分岐メッセージを AI に出させる</a:t>
+              <a:t>「LINE のトーク画面で読むつもりで音読して」と AI に再生成依頼</a:t>
             </a:r>
             <a:endParaRPr lang="en-US" sz="1050" dirty="0"/>
           </a:p>
@@ -5801,7 +5864,7 @@
                 <a:ea typeface="Yu Gothic UI Semibold" pitchFamily="34" charset="-122"/>
                 <a:cs typeface="Yu Gothic UI Semibold" pitchFamily="34" charset="-120"/>
               </a:rPr>
-              <a:t>C. 行動への橋渡し</a:t>
+              <a:t>C. 次回への準備度</a:t>
             </a:r>
             <a:endParaRPr lang="en-US" sz="1200" dirty="0"/>
           </a:p>
@@ -5854,7 +5917,7 @@
                 <a:ea typeface="Yu Gothic UI" pitchFamily="34" charset="-122"/>
                 <a:cs typeface="Yu Gothic UI" pitchFamily="34" charset="-120"/>
               </a:rPr>
-              <a:t>最後の「行動」段階で、面談予約ページへの導線がはっきりしているか</a:t>
+              <a:t>次回そのまま設定画面に貼り付けられる「最終形」になっているか</a:t>
             </a:r>
             <a:endParaRPr lang="en-US" sz="1050" dirty="0"/>
           </a:p>
@@ -5907,7 +5970,7 @@
                 <a:ea typeface="Yu Gothic UI" pitchFamily="34" charset="-122"/>
                 <a:cs typeface="Yu Gothic UI" pitchFamily="34" charset="-120"/>
               </a:rPr>
-              <a:t>予約URL を本文に直接埋め、リッチメニューにも同じ予約ボタンを置く</a:t>
+              <a:t>スプシに「あいさつ文/Day1/Day2/Day3/予約案内」と列を分けて保存する</a:t>
             </a:r>
             <a:endParaRPr lang="en-US" sz="1050" dirty="0"/>
           </a:p>
@@ -6103,7 +6166,7 @@
                 <a:ea typeface="Yu Gothic UI Semibold" pitchFamily="34" charset="-122"/>
                 <a:cs typeface="Yu Gothic UI Semibold" pitchFamily="34" charset="-120"/>
               </a:rPr>
-              <a:t>AI が Web 制作の壁を取り払う</a:t>
+              <a:t>LP は AI で「とりあえず公開」</a:t>
             </a:r>
             <a:endParaRPr lang="en-US" sz="1500" dirty="0"/>
           </a:p>
@@ -6247,7 +6310,7 @@
                 <a:ea typeface="Yu Gothic UI Semibold" pitchFamily="34" charset="-122"/>
                 <a:cs typeface="Yu Gothic UI Semibold" pitchFamily="34" charset="-120"/>
               </a:rPr>
-              <a:t>動線設計には型がある</a:t>
+              <a:t>LINE 構成は「型」で迷わない</a:t>
             </a:r>
             <a:endParaRPr lang="en-US" sz="1500" dirty="0"/>
           </a:p>
@@ -6286,7 +6349,7 @@
                 <a:ea typeface="Yu Gothic UI" pitchFamily="34" charset="-122"/>
                 <a:cs typeface="Yu Gothic UI" pitchFamily="34" charset="-120"/>
               </a:rPr>
-              <a:t>AIDMA に沿って LINE を設計すると、登録→面談予約までの流れがブレない。</a:t>
+              <a:t>AIDMA に沿って配信の流れを言語化すれば、次回の設定で迷わない。</a:t>
             </a:r>
             <a:endParaRPr lang="en-US" sz="1100" dirty="0"/>
           </a:p>
@@ -6391,7 +6454,7 @@
                 <a:ea typeface="Yu Gothic UI Semibold" pitchFamily="34" charset="-122"/>
                 <a:cs typeface="Yu Gothic UI Semibold" pitchFamily="34" charset="-120"/>
               </a:rPr>
-              <a:t>完璧より「まず公開」</a:t>
+              <a:t>次回ですぐ使える形で保存</a:t>
             </a:r>
             <a:endParaRPr lang="en-US" sz="1500" dirty="0"/>
           </a:p>
@@ -6430,7 +6493,7 @@
                 <a:ea typeface="Yu Gothic UI" pitchFamily="34" charset="-122"/>
                 <a:cs typeface="Yu Gothic UI" pitchFamily="34" charset="-120"/>
               </a:rPr>
-              <a:t>公開してから修正を重ねるのがバイブコーディング。AI と一緒に磨き上げる。</a:t>
+              <a:t>LP の URL と LINE 構成文をスプシに整理して持参すれば、次回は設定作業に集中できる。</a:t>
             </a:r>
             <a:endParaRPr lang="en-US" sz="1100" dirty="0"/>
           </a:p>

</xml_diff>